<commit_message>
PPT: quitar mención a NeuronUP (no nombrar a la competencia)
Slide 2 y 10: "plataformas tradicionales" en genérico y "~la mitad de precio
que las plataformas del sector" en vez de nombrar al competidor.

Co-Authored-By: Claude Opus 4.8 <noreply@anthropic.com>
</commit_message>
<xml_diff>
--- a/docs/Trazo-Presentacion.pptx
+++ b/docs/Trazo-Presentacion.pptx
@@ -2374,7 +2374,7 @@
                 <a:ea typeface="Calibri" pitchFamily="34" charset="-122"/>
                 <a:cs typeface="Calibri" pitchFamily="34" charset="-120"/>
               </a:rPr>
-              <a:t>~50% más barato que el plan pro de NeuronUP y sin límite por profesional.</a:t>
+              <a:t>Alrededor de la mitad de precio que las plataformas del sector, y sin límite por profesional.</a:t>
             </a:r>
             <a:endParaRPr lang="en-US" sz="1400" dirty="0"/>
           </a:p>
@@ -4169,7 +4169,7 @@
                 <a:ea typeface="Calibri" pitchFamily="34" charset="-122"/>
                 <a:cs typeface="Calibri" pitchFamily="34" charset="-120"/>
               </a:rPr>
-              <a:t>Las plataformas tradicionales (NeuronUP) cobran licencias caras, se usen o no, y siguen exigiendo montar todo a mano.</a:t>
+              <a:t>Las plataformas tradicionales cobran licencias caras, se usen o no, y siguen exigiendo montar todo a mano.</a:t>
             </a:r>
             <a:endParaRPr lang="en-US" sz="1350" dirty="0"/>
           </a:p>

</xml_diff>

<commit_message>
Contenido y mensaje: objetos reales, trazo con dedo o lápiz, Trazo como plus
- Actividades figurativas (memoria/búsqueda/conteo/parejas) usan objetos reales
  con foto en vez de formas abstractas (fuera estrella/sol/luna/círculo…).
- Trazo: "con el dedo o el lápiz" (psicomotricidad fina, también letras).
- PPT y documento de proyecto: Trazo es un PLUS al trabajo del equipo (que ya
  sigue la evolución a mano), no un sustituto; sin nombrar nº de actividades.
- Documento de proyecto web (docs/trazo-documento-proyecto.html).

Co-Authored-By: Claude Opus 4.8 <noreply@anthropic.com>
</commit_message>
<xml_diff>
--- a/docs/Trazo-Presentacion.pptx
+++ b/docs/Trazo-Presentacion.pptx
@@ -3802,7 +3802,7 @@
                 <a:ea typeface="Bookman Old Style" pitchFamily="34" charset="-122"/>
                 <a:cs typeface="Bookman Old Style" pitchFamily="34" charset="-120"/>
               </a:rPr>
-              <a:t>Montar la estimulación cognitiva</a:t>
+              <a:t>Trazo no sustituye vuestro trabajo:</a:t>
             </a:r>
             <a:endParaRPr lang="en-US" sz="3300" dirty="0"/>
           </a:p>
@@ -3822,7 +3822,7 @@
                 <a:ea typeface="Bookman Old Style" pitchFamily="34" charset="-122"/>
                 <a:cs typeface="Bookman Old Style" pitchFamily="34" charset="-120"/>
               </a:rPr>
-              <a:t>quita tiempo — y deja poca señal</a:t>
+              <a:t>lo hace más fácil y a distancia</a:t>
             </a:r>
             <a:endParaRPr lang="en-US" sz="3300" dirty="0"/>
           </a:p>
@@ -3888,7 +3888,7 @@
                 <a:ea typeface="Calibri" pitchFamily="34" charset="-122"/>
                 <a:cs typeface="Calibri" pitchFamily="34" charset="-120"/>
               </a:rPr>
-              <a:t>Hoy</a:t>
+              <a:t>El equipo ya</a:t>
             </a:r>
             <a:endParaRPr lang="en-US" sz="1300" dirty="0"/>
           </a:p>
@@ -3934,7 +3934,7 @@
                 <a:ea typeface="Calibri" pitchFamily="34" charset="-122"/>
                 <a:cs typeface="Calibri" pitchFamily="34" charset="-120"/>
               </a:rPr>
-              <a:t>Se monta la sesión ejercicio a ejercicio.</a:t>
+              <a:t>Planifica y acompaña cada sesión.</a:t>
             </a:r>
             <a:endParaRPr lang="en-US" sz="1650" dirty="0"/>
           </a:p>
@@ -3958,7 +3958,7 @@
                 <a:ea typeface="Calibri" pitchFamily="34" charset="-122"/>
                 <a:cs typeface="Calibri" pitchFamily="34" charset="-120"/>
               </a:rPr>
-              <a:t>Sobre papel, la evolución no se ve.</a:t>
+              <a:t>Sigue a mano la evolución de cada persona.</a:t>
             </a:r>
             <a:endParaRPr lang="en-US" sz="1650" dirty="0"/>
           </a:p>
@@ -3982,7 +3982,7 @@
                 <a:ea typeface="Calibri" pitchFamily="34" charset="-122"/>
                 <a:cs typeface="Calibri" pitchFamily="34" charset="-120"/>
               </a:rPr>
-              <a:t>Las plataformas del sector son caras y poco ágiles.</a:t>
+              <a:t>Se coordina para planificar las actividades.</a:t>
             </a:r>
             <a:endParaRPr lang="en-US" sz="1650" dirty="0"/>
           </a:p>
@@ -4068,7 +4068,7 @@
                 <a:ea typeface="Calibri" pitchFamily="34" charset="-122"/>
                 <a:cs typeface="Calibri" pitchFamily="34" charset="-120"/>
               </a:rPr>
-              <a:t>Con Trazo</a:t>
+              <a:t>Trazo suma</a:t>
             </a:r>
             <a:endParaRPr lang="en-US" sz="1300" dirty="0"/>
           </a:p>
@@ -4162,7 +4162,7 @@
                 <a:ea typeface="Calibri" pitchFamily="34" charset="-122"/>
                 <a:cs typeface="Calibri" pitchFamily="34" charset="-120"/>
               </a:rPr>
-              <a:t>Compara a cada persona consigo misma y avisa de cambios.</a:t>
+              <a:t>Ve el cambio a distancia y avisa; y es digitalización útil.</a:t>
             </a:r>
             <a:endParaRPr lang="en-US" sz="1650" dirty="0"/>
           </a:p>

</xml_diff>

<commit_message>
PPT/guion: quitar nombres (Laura, competencia) de las diapos 2 y 3
Co-Authored-By: Claude Opus 4.8 <noreply@anthropic.com>
</commit_message>
<xml_diff>
--- a/docs/Trazo-Presentacion.pptx
+++ b/docs/Trazo-Presentacion.pptx
@@ -1220,7 +1220,7 @@
           <a:p>
             <a:r>
               <a:rPr lang="en-US" dirty="0"/>
-              <a:t>No os voy a decir que la competencia es mala. NeuronUP es el referente y hace bien muchas cosas. Pero la empresa que hoy es nuestro cliente ancla, con cinco centros, lo dejó por dos razones muy concretas: les salía caro y se les hacía cuesta arriba en el día a día. Justo ahí queremos estar: más ágil de manejar y más asequible, sin bajar el rigor ni un milímetro.</a:t>
+              <a:t>No os voy a decir que las plataformas de referencia del sector sean malas: hacen bien muchas cosas. Pero muchos centros las dejan por dos razones muy concretas: les salen caras y se les hacen cuesta arriba en el día a día. Justo ahí queremos estar: más ágil de manejar y más asequible, sin bajar el rigor ni un milímetro.</a:t>
             </a:r>
             <a:endParaRPr lang="en-US" dirty="0"/>
           </a:p>
@@ -4539,7 +4539,7 @@
                 <a:ea typeface="Century Gothic" pitchFamily="34" charset="-122"/>
                 <a:cs typeface="Century Gothic" pitchFamily="34" charset="-120"/>
               </a:rPr>
-              <a:t>Las tijeras, el boli rojo y diez personas a la vez</a:t>
+              <a:t>El día a día del centro pesa</a:t>
             </a:r>
             <a:endParaRPr lang="en-US" sz="3400" dirty="0"/>
           </a:p>
@@ -4932,7 +4932,7 @@
                 <a:ea typeface="Century Gothic" pitchFamily="34" charset="-122"/>
                 <a:cs typeface="Century Gothic" pitchFamily="34" charset="-120"/>
               </a:rPr>
-              <a:t>Por qué Laura dejó NeuronUP</a:t>
+              <a:t>Ágil y asequible frente al referente</a:t>
             </a:r>
             <a:endParaRPr lang="en-US" sz="3400" dirty="0"/>
           </a:p>

</xml_diff>